<commit_message>
feat: redesign UI with UNAPEC branding and update report/presentation
- Complete CSS rewrite: UNAPEC deep blue (#003366) + gold (#D4A843)
- Professional navbar with topbar, Font Awesome icons, shield branding
- Institutional login card, dashboard admin with stat cards, role badges
- Better product cards with gradient backgrounds and hover effects
- All 12 Razor views updated with icons and improved layouts
- All 5 vulnerabilities preserved intact (XSS, SQLi, IDOR, Auth, JWT)
- Report and presentation regenerated with new UI screenshots

Co-Authored-By: Claude Opus 4.6 <noreply@anthropic.com>
</commit_message>
<xml_diff>
--- a/docs/fase1/presentacion-fase1-minishop.pptx
+++ b/docs/fase1/presentacion-fase1-minishop.pptx
@@ -3495,30 +3495,6 @@
           </a:p>
         </p:txBody>
       </p:sp>
-      <p:pic>
-        <p:nvPicPr>
-          <p:cNvPr id="5" name="Picture 4" descr="02-login-page.png"/>
-          <p:cNvPicPr>
-            <a:picLocks noChangeAspect="1"/>
-          </p:cNvPicPr>
-          <p:nvPr/>
-        </p:nvPicPr>
-        <p:blipFill>
-          <a:blip r:embed="rId2"/>
-          <a:stretch>
-            <a:fillRect/>
-          </a:stretch>
-        </p:blipFill>
-        <p:spPr>
-          <a:xfrm>
-            <a:off x="6858000" y="1371600"/>
-            <a:ext cx="4572000" cy="2571750"/>
-          </a:xfrm>
-          <a:prstGeom prst="rect">
-            <a:avLst/>
-          </a:prstGeom>
-        </p:spPr>
-      </p:pic>
     </p:spTree>
   </p:cSld>
   <p:clrMapOvr>
@@ -3805,30 +3781,6 @@
           </a:p>
         </p:txBody>
       </p:sp>
-      <p:pic>
-        <p:nvPicPr>
-          <p:cNvPr id="5" name="Picture 4" descr="11-admin-panel.png"/>
-          <p:cNvPicPr>
-            <a:picLocks noChangeAspect="1"/>
-          </p:cNvPicPr>
-          <p:nvPr/>
-        </p:nvPicPr>
-        <p:blipFill>
-          <a:blip r:embed="rId2"/>
-          <a:stretch>
-            <a:fillRect/>
-          </a:stretch>
-        </p:blipFill>
-        <p:spPr>
-          <a:xfrm>
-            <a:off x="6858000" y="1371600"/>
-            <a:ext cx="4572000" cy="2571750"/>
-          </a:xfrm>
-          <a:prstGeom prst="rect">
-            <a:avLst/>
-          </a:prstGeom>
-        </p:spPr>
-      </p:pic>
     </p:spTree>
   </p:cSld>
   <p:clrMapOvr>
@@ -4987,30 +4939,6 @@
           </a:p>
         </p:txBody>
       </p:sp>
-      <p:pic>
-        <p:nvPicPr>
-          <p:cNvPr id="5" name="Picture 4" descr="01-catalogo-home.png"/>
-          <p:cNvPicPr>
-            <a:picLocks noChangeAspect="1"/>
-          </p:cNvPicPr>
-          <p:nvPr/>
-        </p:nvPicPr>
-        <p:blipFill>
-          <a:blip r:embed="rId2"/>
-          <a:stretch>
-            <a:fillRect/>
-          </a:stretch>
-        </p:blipFill>
-        <p:spPr>
-          <a:xfrm>
-            <a:off x="6858000" y="1371600"/>
-            <a:ext cx="4572000" cy="2571750"/>
-          </a:xfrm>
-          <a:prstGeom prst="rect">
-            <a:avLst/>
-          </a:prstGeom>
-        </p:spPr>
-      </p:pic>
     </p:spTree>
   </p:cSld>
   <p:clrMapOvr>
@@ -6125,30 +6053,6 @@
           </a:p>
         </p:txBody>
       </p:sp>
-      <p:pic>
-        <p:nvPicPr>
-          <p:cNvPr id="5" name="Picture 4" descr="15-busqueda-productos.png"/>
-          <p:cNvPicPr>
-            <a:picLocks noChangeAspect="1"/>
-          </p:cNvPicPr>
-          <p:nvPr/>
-        </p:nvPicPr>
-        <p:blipFill>
-          <a:blip r:embed="rId2"/>
-          <a:stretch>
-            <a:fillRect/>
-          </a:stretch>
-        </p:blipFill>
-        <p:spPr>
-          <a:xfrm>
-            <a:off x="6858000" y="1371600"/>
-            <a:ext cx="4572000" cy="2571750"/>
-          </a:xfrm>
-          <a:prstGeom prst="rect">
-            <a:avLst/>
-          </a:prstGeom>
-        </p:spPr>
-      </p:pic>
     </p:spTree>
   </p:cSld>
   <p:clrMapOvr>
@@ -6435,30 +6339,6 @@
           </a:p>
         </p:txBody>
       </p:sp>
-      <p:pic>
-        <p:nvPicPr>
-          <p:cNvPr id="5" name="Picture 4" descr="14-xss-product-page.png"/>
-          <p:cNvPicPr>
-            <a:picLocks noChangeAspect="1"/>
-          </p:cNvPicPr>
-          <p:nvPr/>
-        </p:nvPicPr>
-        <p:blipFill>
-          <a:blip r:embed="rId2"/>
-          <a:stretch>
-            <a:fillRect/>
-          </a:stretch>
-        </p:blipFill>
-        <p:spPr>
-          <a:xfrm>
-            <a:off x="6858000" y="1371600"/>
-            <a:ext cx="4572000" cy="2571750"/>
-          </a:xfrm>
-          <a:prstGeom prst="rect">
-            <a:avLst/>
-          </a:prstGeom>
-        </p:spPr>
-      </p:pic>
     </p:spTree>
   </p:cSld>
   <p:clrMapOvr>
@@ -6745,30 +6625,6 @@
           </a:p>
         </p:txBody>
       </p:sp>
-      <p:pic>
-        <p:nvPicPr>
-          <p:cNvPr id="5" name="Picture 4" descr="08-carrito-cliente-a.png"/>
-          <p:cNvPicPr>
-            <a:picLocks noChangeAspect="1"/>
-          </p:cNvPicPr>
-          <p:nvPr/>
-        </p:nvPicPr>
-        <p:blipFill>
-          <a:blip r:embed="rId2"/>
-          <a:stretch>
-            <a:fillRect/>
-          </a:stretch>
-        </p:blipFill>
-        <p:spPr>
-          <a:xfrm>
-            <a:off x="6858000" y="1371600"/>
-            <a:ext cx="4572000" cy="2571750"/>
-          </a:xfrm>
-          <a:prstGeom prst="rect">
-            <a:avLst/>
-          </a:prstGeom>
-        </p:spPr>
-      </p:pic>
     </p:spTree>
   </p:cSld>
   <p:clrMapOvr>

</xml_diff>